<commit_message>
Add Arabic slides + cover pages; build tooling for bilingual deliverables
- docs/presentation/slides-ar.md: full Arabic (RTL) slide deck
- cover pages added to English report.md + slides.md (university/supervisor as
  fillable placeholders «...»; real student names)
- docs/_sanitize_for_pdf.py: maps math/arrow glyphs to ASCII so the Arabic PDF
  renders under Amiri (which lacks those glyphs); DOCX/PPTX keep originals
- Makefile `docs-ar` target; Amiri font used for Arabic PDFs (RTL, verified)
- built: slides-ar.pptx (editable), slides-ar.pdf (RTL, images, 0 missing glyphs);
  rebuilt English report/slides with covers

Arabic report (report-ar.md) translation in progress; its docx/pdf follow.

Co-Authored-By: Claude Opus 4.8 (1M context) <noreply@anthropic.com>
</commit_message>
<xml_diff>
--- a/docs/build/slides.pptx
+++ b/docs/build/slides.pptx
@@ -4632,7 +4632,15 @@
             </a:pPr>
             <a:r>
               <a:rPr b="1"/>
-              <a:t>Mulham Fetna · Mohammad Zein Qabbani</a:t>
+              <a:t>«University Name — Faculty»</a:t>
+            </a:r>
+            <a:r>
+              <a:rPr/>
+              <a:t> · </a:t>
+            </a:r>
+            <a:r>
+              <a:rPr b="1"/>
+              <a:t>«Department / Program»</a:t>
             </a:r>
           </a:p>
           <a:p>
@@ -4641,6 +4649,48 @@
             </a:pPr>
             <a:r>
               <a:rPr/>
+              <a:t>Students: </a:t>
+            </a:r>
+            <a:r>
+              <a:rPr b="1"/>
+              <a:t>Mulham Fetna</a:t>
+            </a:r>
+            <a:r>
+              <a:rPr/>
+              <a:t> · </a:t>
+            </a:r>
+            <a:r>
+              <a:rPr b="1"/>
+              <a:t>Mohammad Zein Qabbani</a:t>
+            </a:r>
+          </a:p>
+          <a:p>
+            <a:pPr lvl="0" indent="0" marL="0">
+              <a:buNone/>
+            </a:pPr>
+            <a:r>
+              <a:rPr/>
+              <a:t>Supervisor: </a:t>
+            </a:r>
+            <a:r>
+              <a:rPr b="1"/>
+              <a:t>«Dr. Supervisor Name»</a:t>
+            </a:r>
+            <a:r>
+              <a:rPr/>
+              <a:t> · Academic year: </a:t>
+            </a:r>
+            <a:r>
+              <a:rPr b="1"/>
+              <a:t>«2025–2026»</a:t>
+            </a:r>
+          </a:p>
+          <a:p>
+            <a:pPr lvl="0" indent="0" marL="0">
+              <a:buNone/>
+            </a:pPr>
+            <a:r>
+              <a:rPr i="1"/>
               <a:t>Research seminar — CNN classification of PMSM operating states from time–frequency images</a:t>
             </a:r>
           </a:p>

</xml_diff>